<commit_message>
fix: renumber figures to match order of first appearance in text
Previous order of figure citations: 1, 4, 2, 3, 5
Corrected order: 1, 2, 3, 4, 5

Remapping:
- Figure 1 (PRISMA flowchart) → Figure 1 (unchanged)
- Figure 4 (conceptual framework) → Figure 2
- Figure 2 (gap risk matrix) → Figure 3
- Figure 3 (timeline) → Figure 4
- Figure 5 (severity bar) → Figure 5 (unchanged)

Updated: in-text citations, build scripts, figure captions,
combined PPTX files, and individual figure PPTs.

Co-Authored-By: Tatsuki Onishi <bougtoir@gmail.com>
</commit_message>
<xml_diff>
--- a/wada-tue-scoping-review/manuscripts/SCJ_Figures_English.pptx
+++ b/wada-tue-scoping-review/manuscripts/SCJ_Figures_English.pptx
@@ -3226,6 +3226,108 @@
       </p:sp>
       <p:pic>
         <p:nvPicPr>
+          <p:cNvPr id="3" name="Picture 2" descr="fig4_conceptual_framework.png"/>
+          <p:cNvPicPr>
+            <a:picLocks noChangeAspect="1"/>
+          </p:cNvPicPr>
+          <p:nvPr/>
+        </p:nvPicPr>
+        <p:blipFill>
+          <a:blip r:embed="rId2"/>
+          <a:stretch>
+            <a:fillRect/>
+          </a:stretch>
+        </p:blipFill>
+        <p:spPr>
+          <a:xfrm>
+            <a:off x="3227482" y="914400"/>
+            <a:ext cx="5736730" cy="4572000"/>
+          </a:xfrm>
+          <a:prstGeom prst="rect">
+            <a:avLst/>
+          </a:prstGeom>
+        </p:spPr>
+      </p:pic>
+      <p:sp>
+        <p:nvSpPr>
+          <p:cNvPr id="4" name="TextBox 3"/>
+          <p:cNvSpPr txBox="1"/>
+          <p:nvPr/>
+        </p:nvSpPr>
+        <p:spPr>
+          <a:xfrm>
+            <a:off x="457200" y="5943600"/>
+            <a:ext cx="11247120" cy="731520"/>
+          </a:xfrm>
+          <a:prstGeom prst="rect">
+            <a:avLst/>
+          </a:prstGeom>
+          <a:noFill/>
+        </p:spPr>
+        <p:txBody>
+          <a:bodyPr wrap="square">
+            <a:spAutoFit/>
+          </a:bodyPr>
+          <a:lstStyle/>
+          <a:p>
+            <a:pPr algn="ctr"/>
+            <a:r>
+              <a:rPr sz="1400" i="1"/>
+              <a:t>Figure 2. Conceptual framework: structural drivers of clinical-competition divergence.</a:t>
+            </a:r>
+          </a:p>
+        </p:txBody>
+      </p:sp>
+    </p:spTree>
+  </p:cSld>
+  <p:clrMapOvr>
+    <a:masterClrMapping/>
+  </p:clrMapOvr>
+</p:sld>
+</file>
+
+<file path=ppt/slides/slide3.xml><?xml version="1.0" encoding="utf-8"?>
+<p:sld xmlns:a="http://schemas.openxmlformats.org/drawingml/2006/main" xmlns:p="http://schemas.openxmlformats.org/presentationml/2006/main" xmlns:r="http://schemas.openxmlformats.org/officeDocument/2006/relationships">
+  <p:cSld>
+    <p:spTree>
+      <p:nvGrpSpPr>
+        <p:cNvPr id="1" name=""/>
+        <p:cNvGrpSpPr/>
+        <p:nvPr/>
+      </p:nvGrpSpPr>
+      <p:grpSpPr/>
+      <p:sp>
+        <p:nvSpPr>
+          <p:cNvPr id="2" name="TextBox 1"/>
+          <p:cNvSpPr txBox="1"/>
+          <p:nvPr/>
+        </p:nvSpPr>
+        <p:spPr>
+          <a:xfrm>
+            <a:off x="457200" y="182880"/>
+            <a:ext cx="11247120" cy="548640"/>
+          </a:xfrm>
+          <a:prstGeom prst="rect">
+            <a:avLst/>
+          </a:prstGeom>
+          <a:noFill/>
+        </p:spPr>
+        <p:txBody>
+          <a:bodyPr wrap="square">
+            <a:spAutoFit/>
+          </a:bodyPr>
+          <a:lstStyle/>
+          <a:p>
+            <a:pPr algn="ctr"/>
+            <a:r>
+              <a:rPr b="1" sz="2400"/>
+              <a:t>Figure 3</a:t>
+            </a:r>
+          </a:p>
+        </p:txBody>
+      </p:sp>
+      <p:pic>
+        <p:nvPicPr>
           <p:cNvPr id="3" name="Picture 2" descr="fig2_gap_heatmap.png"/>
           <p:cNvPicPr>
             <a:picLocks noChangeAspect="1"/>
@@ -3273,7 +3375,7 @@
             <a:pPr algn="ctr"/>
             <a:r>
               <a:rPr sz="1400" i="1"/>
-              <a:t>Figure 2. Clinical-competition gap risk matrix by disease area and assessment dimension.</a:t>
+              <a:t>Figure 3. Clinical-competition gap risk matrix by disease area and assessment dimension.</a:t>
             </a:r>
           </a:p>
         </p:txBody>
@@ -3286,7 +3388,7 @@
 </p:sld>
 </file>
 
-<file path=ppt/slides/slide3.xml><?xml version="1.0" encoding="utf-8"?>
+<file path=ppt/slides/slide4.xml><?xml version="1.0" encoding="utf-8"?>
 <p:sld xmlns:a="http://schemas.openxmlformats.org/drawingml/2006/main" xmlns:p="http://schemas.openxmlformats.org/presentationml/2006/main" xmlns:r="http://schemas.openxmlformats.org/officeDocument/2006/relationships">
   <p:cSld>
     <p:spTree>
@@ -3321,7 +3423,7 @@
             <a:pPr algn="ctr"/>
             <a:r>
               <a:rPr b="1" sz="2400"/>
-              <a:t>Figure 3</a:t>
+              <a:t>Figure 4</a:t>
             </a:r>
           </a:p>
         </p:txBody>
@@ -3375,109 +3477,7 @@
             <a:pPr algn="ctr"/>
             <a:r>
               <a:rPr sz="1400" i="1"/>
-              <a:t>Figure 3. Timeline of clinical guideline updates versus WADA TUE regulatory changes (2018–2026).</a:t>
-            </a:r>
-          </a:p>
-        </p:txBody>
-      </p:sp>
-    </p:spTree>
-  </p:cSld>
-  <p:clrMapOvr>
-    <a:masterClrMapping/>
-  </p:clrMapOvr>
-</p:sld>
-</file>
-
-<file path=ppt/slides/slide4.xml><?xml version="1.0" encoding="utf-8"?>
-<p:sld xmlns:a="http://schemas.openxmlformats.org/drawingml/2006/main" xmlns:p="http://schemas.openxmlformats.org/presentationml/2006/main" xmlns:r="http://schemas.openxmlformats.org/officeDocument/2006/relationships">
-  <p:cSld>
-    <p:spTree>
-      <p:nvGrpSpPr>
-        <p:cNvPr id="1" name=""/>
-        <p:cNvGrpSpPr/>
-        <p:nvPr/>
-      </p:nvGrpSpPr>
-      <p:grpSpPr/>
-      <p:sp>
-        <p:nvSpPr>
-          <p:cNvPr id="2" name="TextBox 1"/>
-          <p:cNvSpPr txBox="1"/>
-          <p:nvPr/>
-        </p:nvSpPr>
-        <p:spPr>
-          <a:xfrm>
-            <a:off x="457200" y="182880"/>
-            <a:ext cx="11247120" cy="548640"/>
-          </a:xfrm>
-          <a:prstGeom prst="rect">
-            <a:avLst/>
-          </a:prstGeom>
-          <a:noFill/>
-        </p:spPr>
-        <p:txBody>
-          <a:bodyPr wrap="square">
-            <a:spAutoFit/>
-          </a:bodyPr>
-          <a:lstStyle/>
-          <a:p>
-            <a:pPr algn="ctr"/>
-            <a:r>
-              <a:rPr b="1" sz="2400"/>
-              <a:t>Figure 4</a:t>
-            </a:r>
-          </a:p>
-        </p:txBody>
-      </p:sp>
-      <p:pic>
-        <p:nvPicPr>
-          <p:cNvPr id="3" name="Picture 2" descr="fig4_conceptual_framework.png"/>
-          <p:cNvPicPr>
-            <a:picLocks noChangeAspect="1"/>
-          </p:cNvPicPr>
-          <p:nvPr/>
-        </p:nvPicPr>
-        <p:blipFill>
-          <a:blip r:embed="rId2"/>
-          <a:stretch>
-            <a:fillRect/>
-          </a:stretch>
-        </p:blipFill>
-        <p:spPr>
-          <a:xfrm>
-            <a:off x="3227482" y="914400"/>
-            <a:ext cx="5736730" cy="4572000"/>
-          </a:xfrm>
-          <a:prstGeom prst="rect">
-            <a:avLst/>
-          </a:prstGeom>
-        </p:spPr>
-      </p:pic>
-      <p:sp>
-        <p:nvSpPr>
-          <p:cNvPr id="4" name="TextBox 3"/>
-          <p:cNvSpPr txBox="1"/>
-          <p:nvPr/>
-        </p:nvSpPr>
-        <p:spPr>
-          <a:xfrm>
-            <a:off x="457200" y="5943600"/>
-            <a:ext cx="11247120" cy="731520"/>
-          </a:xfrm>
-          <a:prstGeom prst="rect">
-            <a:avLst/>
-          </a:prstGeom>
-          <a:noFill/>
-        </p:spPr>
-        <p:txBody>
-          <a:bodyPr wrap="square">
-            <a:spAutoFit/>
-          </a:bodyPr>
-          <a:lstStyle/>
-          <a:p>
-            <a:pPr algn="ctr"/>
-            <a:r>
-              <a:rPr sz="1400" i="1"/>
-              <a:t>Figure 4. Conceptual framework: structural drivers of clinical-competition divergence.</a:t>
+              <a:t>Figure 4. Timeline of clinical guideline updates versus WADA TUE regulatory changes (2018–2026).</a:t>
             </a:r>
           </a:p>
         </p:txBody>

</xml_diff>

<commit_message>
SCJ revision: restructure manuscript, update figures, add response and PRISMA checklist
Co-Authored-By: Tatsuki Onishi <bougtoir@gmail.com>
</commit_message>
<xml_diff>
--- a/wada-tue-scoping-review/manuscripts/SCJ_Figures_English.pptx
+++ b/wada-tue-scoping-review/manuscripts/SCJ_Figures_English.pptx
@@ -3546,8 +3546,8 @@
         </p:blipFill>
         <p:spPr>
           <a:xfrm>
-            <a:off x="1848563" y="914400"/>
-            <a:ext cx="8494568" cy="4572000"/>
+            <a:off x="1855791" y="914400"/>
+            <a:ext cx="8480113" cy="4572000"/>
           </a:xfrm>
           <a:prstGeom prst="rect">
             <a:avLst/>

</xml_diff>

<commit_message>
SCJ resubmission: Vancouver reference renumbering, red/blue marked mainbody, clean previous-version figures, updated response and PRISMA checklist
Co-Authored-By: Tatsuki Onishi <bougtoir@gmail.com>
</commit_message>
<xml_diff>
--- a/wada-tue-scoping-review/manuscripts/SCJ_Figures_English.pptx
+++ b/wada-tue-scoping-review/manuscripts/SCJ_Figures_English.pptx
@@ -3092,39 +3092,9 @@
         <p:nvPr/>
       </p:nvGrpSpPr>
       <p:grpSpPr/>
-      <p:sp>
-        <p:nvSpPr>
-          <p:cNvPr id="2" name="TextBox 1"/>
-          <p:cNvSpPr txBox="1"/>
-          <p:nvPr/>
-        </p:nvSpPr>
-        <p:spPr>
-          <a:xfrm>
-            <a:off x="457200" y="182880"/>
-            <a:ext cx="11247120" cy="548640"/>
-          </a:xfrm>
-          <a:prstGeom prst="rect">
-            <a:avLst/>
-          </a:prstGeom>
-          <a:noFill/>
-        </p:spPr>
-        <p:txBody>
-          <a:bodyPr wrap="square">
-            <a:spAutoFit/>
-          </a:bodyPr>
-          <a:lstStyle/>
-          <a:p>
-            <a:pPr algn="ctr"/>
-            <a:r>
-              <a:rPr b="1" sz="2400"/>
-              <a:t>Figure 1</a:t>
-            </a:r>
-          </a:p>
-        </p:txBody>
-      </p:sp>
       <p:pic>
         <p:nvPicPr>
-          <p:cNvPr id="3" name="Picture 2" descr="fig1_prisma_flowchart.png"/>
+          <p:cNvPr id="2" name="Picture 1" descr="fig1_prisma_flowchart.png"/>
           <p:cNvPicPr>
             <a:picLocks noChangeAspect="1"/>
           </p:cNvPicPr>
@@ -3138,44 +3108,14 @@
         </p:blipFill>
         <p:spPr>
           <a:xfrm>
-            <a:off x="4194049" y="914400"/>
-            <a:ext cx="3803596" cy="4572000"/>
+            <a:off x="811327" y="457200"/>
+            <a:ext cx="10569041" cy="5943600"/>
           </a:xfrm>
           <a:prstGeom prst="rect">
             <a:avLst/>
           </a:prstGeom>
         </p:spPr>
       </p:pic>
-      <p:sp>
-        <p:nvSpPr>
-          <p:cNvPr id="4" name="TextBox 3"/>
-          <p:cNvSpPr txBox="1"/>
-          <p:nvPr/>
-        </p:nvSpPr>
-        <p:spPr>
-          <a:xfrm>
-            <a:off x="457200" y="5943600"/>
-            <a:ext cx="11247120" cy="731520"/>
-          </a:xfrm>
-          <a:prstGeom prst="rect">
-            <a:avLst/>
-          </a:prstGeom>
-          <a:noFill/>
-        </p:spPr>
-        <p:txBody>
-          <a:bodyPr wrap="square">
-            <a:spAutoFit/>
-          </a:bodyPr>
-          <a:lstStyle/>
-          <a:p>
-            <a:pPr algn="ctr"/>
-            <a:r>
-              <a:rPr sz="1400" i="1"/>
-              <a:t>Figure 1. PRISMA-ScR flow diagram illustrating the source selection process.</a:t>
-            </a:r>
-          </a:p>
-        </p:txBody>
-      </p:sp>
     </p:spTree>
   </p:cSld>
   <p:clrMapOvr>
@@ -3194,39 +3134,9 @@
         <p:nvPr/>
       </p:nvGrpSpPr>
       <p:grpSpPr/>
-      <p:sp>
-        <p:nvSpPr>
-          <p:cNvPr id="2" name="TextBox 1"/>
-          <p:cNvSpPr txBox="1"/>
-          <p:nvPr/>
-        </p:nvSpPr>
-        <p:spPr>
-          <a:xfrm>
-            <a:off x="457200" y="182880"/>
-            <a:ext cx="11247120" cy="548640"/>
-          </a:xfrm>
-          <a:prstGeom prst="rect">
-            <a:avLst/>
-          </a:prstGeom>
-          <a:noFill/>
-        </p:spPr>
-        <p:txBody>
-          <a:bodyPr wrap="square">
-            <a:spAutoFit/>
-          </a:bodyPr>
-          <a:lstStyle/>
-          <a:p>
-            <a:pPr algn="ctr"/>
-            <a:r>
-              <a:rPr b="1" sz="2400"/>
-              <a:t>Figure 2</a:t>
-            </a:r>
-          </a:p>
-        </p:txBody>
-      </p:sp>
       <p:pic>
         <p:nvPicPr>
-          <p:cNvPr id="3" name="Picture 2" descr="fig2_gap_heatmap.png"/>
+          <p:cNvPr id="2" name="Picture 1" descr="fig2_gap_heatmap.png"/>
           <p:cNvPicPr>
             <a:picLocks noChangeAspect="1"/>
           </p:cNvPicPr>
@@ -3240,44 +3150,14 @@
         </p:blipFill>
         <p:spPr>
           <a:xfrm>
-            <a:off x="2144586" y="914400"/>
-            <a:ext cx="7902522" cy="4572000"/>
+            <a:off x="954619" y="457200"/>
+            <a:ext cx="10282456" cy="5943600"/>
           </a:xfrm>
           <a:prstGeom prst="rect">
             <a:avLst/>
           </a:prstGeom>
         </p:spPr>
       </p:pic>
-      <p:sp>
-        <p:nvSpPr>
-          <p:cNvPr id="4" name="TextBox 3"/>
-          <p:cNvSpPr txBox="1"/>
-          <p:nvPr/>
-        </p:nvSpPr>
-        <p:spPr>
-          <a:xfrm>
-            <a:off x="457200" y="5943600"/>
-            <a:ext cx="11247120" cy="731520"/>
-          </a:xfrm>
-          <a:prstGeom prst="rect">
-            <a:avLst/>
-          </a:prstGeom>
-          <a:noFill/>
-        </p:spPr>
-        <p:txBody>
-          <a:bodyPr wrap="square">
-            <a:spAutoFit/>
-          </a:bodyPr>
-          <a:lstStyle/>
-          <a:p>
-            <a:pPr algn="ctr"/>
-            <a:r>
-              <a:rPr sz="1400" i="1"/>
-              <a:t>Figure 2. Clinical-competition gap risk matrix by disease area and assessment dimension.</a:t>
-            </a:r>
-          </a:p>
-        </p:txBody>
-      </p:sp>
     </p:spTree>
   </p:cSld>
   <p:clrMapOvr>
@@ -3296,39 +3176,9 @@
         <p:nvPr/>
       </p:nvGrpSpPr>
       <p:grpSpPr/>
-      <p:sp>
-        <p:nvSpPr>
-          <p:cNvPr id="2" name="TextBox 1"/>
-          <p:cNvSpPr txBox="1"/>
-          <p:nvPr/>
-        </p:nvSpPr>
-        <p:spPr>
-          <a:xfrm>
-            <a:off x="457200" y="182880"/>
-            <a:ext cx="11247120" cy="548640"/>
-          </a:xfrm>
-          <a:prstGeom prst="rect">
-            <a:avLst/>
-          </a:prstGeom>
-          <a:noFill/>
-        </p:spPr>
-        <p:txBody>
-          <a:bodyPr wrap="square">
-            <a:spAutoFit/>
-          </a:bodyPr>
-          <a:lstStyle/>
-          <a:p>
-            <a:pPr algn="ctr"/>
-            <a:r>
-              <a:rPr b="1" sz="2400"/>
-              <a:t>Figure 3</a:t>
-            </a:r>
-          </a:p>
-        </p:txBody>
-      </p:sp>
       <p:pic>
         <p:nvPicPr>
-          <p:cNvPr id="3" name="Picture 2" descr="fig3_timeline.png"/>
+          <p:cNvPr id="2" name="Picture 1" descr="fig3_timeline.png"/>
           <p:cNvPicPr>
             <a:picLocks noChangeAspect="1"/>
           </p:cNvPicPr>
@@ -3342,44 +3192,14 @@
         </p:blipFill>
         <p:spPr>
           <a:xfrm>
-            <a:off x="1066647" y="914400"/>
-            <a:ext cx="10058400" cy="4278211"/>
+            <a:off x="811327" y="457200"/>
+            <a:ext cx="10569041" cy="5943600"/>
           </a:xfrm>
           <a:prstGeom prst="rect">
             <a:avLst/>
           </a:prstGeom>
         </p:spPr>
       </p:pic>
-      <p:sp>
-        <p:nvSpPr>
-          <p:cNvPr id="4" name="TextBox 3"/>
-          <p:cNvSpPr txBox="1"/>
-          <p:nvPr/>
-        </p:nvSpPr>
-        <p:spPr>
-          <a:xfrm>
-            <a:off x="457200" y="5943600"/>
-            <a:ext cx="11247120" cy="731520"/>
-          </a:xfrm>
-          <a:prstGeom prst="rect">
-            <a:avLst/>
-          </a:prstGeom>
-          <a:noFill/>
-        </p:spPr>
-        <p:txBody>
-          <a:bodyPr wrap="square">
-            <a:spAutoFit/>
-          </a:bodyPr>
-          <a:lstStyle/>
-          <a:p>
-            <a:pPr algn="ctr"/>
-            <a:r>
-              <a:rPr sz="1400" i="1"/>
-              <a:t>Figure 3. Timeline of clinical guideline updates versus WADA TUE regulatory changes (2018–2026).</a:t>
-            </a:r>
-          </a:p>
-        </p:txBody>
-      </p:sp>
     </p:spTree>
   </p:cSld>
   <p:clrMapOvr>
@@ -3398,39 +3218,9 @@
         <p:nvPr/>
       </p:nvGrpSpPr>
       <p:grpSpPr/>
-      <p:sp>
-        <p:nvSpPr>
-          <p:cNvPr id="2" name="TextBox 1"/>
-          <p:cNvSpPr txBox="1"/>
-          <p:nvPr/>
-        </p:nvSpPr>
-        <p:spPr>
-          <a:xfrm>
-            <a:off x="457200" y="182880"/>
-            <a:ext cx="11247120" cy="548640"/>
-          </a:xfrm>
-          <a:prstGeom prst="rect">
-            <a:avLst/>
-          </a:prstGeom>
-          <a:noFill/>
-        </p:spPr>
-        <p:txBody>
-          <a:bodyPr wrap="square">
-            <a:spAutoFit/>
-          </a:bodyPr>
-          <a:lstStyle/>
-          <a:p>
-            <a:pPr algn="ctr"/>
-            <a:r>
-              <a:rPr b="1" sz="2400"/>
-              <a:t>Figure 4</a:t>
-            </a:r>
-          </a:p>
-        </p:txBody>
-      </p:sp>
       <p:pic>
         <p:nvPicPr>
-          <p:cNvPr id="3" name="Picture 2" descr="fig4_conceptual_framework.png"/>
+          <p:cNvPr id="2" name="Picture 1" descr="fig4_conceptual_framework.png"/>
           <p:cNvPicPr>
             <a:picLocks noChangeAspect="1"/>
           </p:cNvPicPr>
@@ -3444,44 +3234,14 @@
         </p:blipFill>
         <p:spPr>
           <a:xfrm>
-            <a:off x="3227482" y="914400"/>
-            <a:ext cx="5736730" cy="4572000"/>
+            <a:off x="811327" y="457200"/>
+            <a:ext cx="10569041" cy="5943600"/>
           </a:xfrm>
           <a:prstGeom prst="rect">
             <a:avLst/>
           </a:prstGeom>
         </p:spPr>
       </p:pic>
-      <p:sp>
-        <p:nvSpPr>
-          <p:cNvPr id="4" name="TextBox 3"/>
-          <p:cNvSpPr txBox="1"/>
-          <p:nvPr/>
-        </p:nvSpPr>
-        <p:spPr>
-          <a:xfrm>
-            <a:off x="457200" y="5943600"/>
-            <a:ext cx="11247120" cy="731520"/>
-          </a:xfrm>
-          <a:prstGeom prst="rect">
-            <a:avLst/>
-          </a:prstGeom>
-          <a:noFill/>
-        </p:spPr>
-        <p:txBody>
-          <a:bodyPr wrap="square">
-            <a:spAutoFit/>
-          </a:bodyPr>
-          <a:lstStyle/>
-          <a:p>
-            <a:pPr algn="ctr"/>
-            <a:r>
-              <a:rPr sz="1400" i="1"/>
-              <a:t>Figure 4. Conceptual framework: structural drivers of clinical-competition divergence.</a:t>
-            </a:r>
-          </a:p>
-        </p:txBody>
-      </p:sp>
     </p:spTree>
   </p:cSld>
   <p:clrMapOvr>
@@ -3500,39 +3260,9 @@
         <p:nvPr/>
       </p:nvGrpSpPr>
       <p:grpSpPr/>
-      <p:sp>
-        <p:nvSpPr>
-          <p:cNvPr id="2" name="TextBox 1"/>
-          <p:cNvSpPr txBox="1"/>
-          <p:nvPr/>
-        </p:nvSpPr>
-        <p:spPr>
-          <a:xfrm>
-            <a:off x="457200" y="182880"/>
-            <a:ext cx="11247120" cy="548640"/>
-          </a:xfrm>
-          <a:prstGeom prst="rect">
-            <a:avLst/>
-          </a:prstGeom>
-          <a:noFill/>
-        </p:spPr>
-        <p:txBody>
-          <a:bodyPr wrap="square">
-            <a:spAutoFit/>
-          </a:bodyPr>
-          <a:lstStyle/>
-          <a:p>
-            <a:pPr algn="ctr"/>
-            <a:r>
-              <a:rPr b="1" sz="2400"/>
-              <a:t>Figure 5</a:t>
-            </a:r>
-          </a:p>
-        </p:txBody>
-      </p:sp>
       <p:pic>
         <p:nvPicPr>
-          <p:cNvPr id="3" name="Picture 2" descr="fig5_severity_bar.png"/>
+          <p:cNvPr id="2" name="Picture 1" descr="fig5_severity_bar.png"/>
           <p:cNvPicPr>
             <a:picLocks noChangeAspect="1"/>
           </p:cNvPicPr>
@@ -3546,44 +3276,14 @@
         </p:blipFill>
         <p:spPr>
           <a:xfrm>
-            <a:off x="1855791" y="914400"/>
-            <a:ext cx="8480113" cy="4572000"/>
+            <a:off x="812647" y="457200"/>
+            <a:ext cx="10566400" cy="5943600"/>
           </a:xfrm>
           <a:prstGeom prst="rect">
             <a:avLst/>
           </a:prstGeom>
         </p:spPr>
       </p:pic>
-      <p:sp>
-        <p:nvSpPr>
-          <p:cNvPr id="4" name="TextBox 3"/>
-          <p:cNvSpPr txBox="1"/>
-          <p:nvPr/>
-        </p:nvSpPr>
-        <p:spPr>
-          <a:xfrm>
-            <a:off x="457200" y="5943600"/>
-            <a:ext cx="11247120" cy="731520"/>
-          </a:xfrm>
-          <a:prstGeom prst="rect">
-            <a:avLst/>
-          </a:prstGeom>
-          <a:noFill/>
-        </p:spPr>
-        <p:txBody>
-          <a:bodyPr wrap="square">
-            <a:spAutoFit/>
-          </a:bodyPr>
-          <a:lstStyle/>
-          <a:p>
-            <a:pPr algn="ctr"/>
-            <a:r>
-              <a:rPr sz="1400" i="1"/>
-              <a:t>Figure 5. Clinical-competition gap severity by disease area and assessment dimension.</a:t>
-            </a:r>
-          </a:p>
-        </p:txBody>
-      </p:sp>
     </p:spTree>
   </p:cSld>
   <p:clrMapOvr>

</xml_diff>

<commit_message>
fix(figures): restore colorbar legend for Figure 2 and chart legend for Figure 5; keep no titles/captions
Co-Authored-By: Tatsuki Onishi <bougtoir@gmail.com>
</commit_message>
<xml_diff>
--- a/wada-tue-scoping-review/manuscripts/SCJ_Figures_English.pptx
+++ b/wada-tue-scoping-review/manuscripts/SCJ_Figures_English.pptx
@@ -3150,8 +3150,8 @@
         </p:blipFill>
         <p:spPr>
           <a:xfrm>
-            <a:off x="954619" y="457200"/>
-            <a:ext cx="10282456" cy="5943600"/>
+            <a:off x="887177" y="457200"/>
+            <a:ext cx="10417340" cy="5943600"/>
           </a:xfrm>
           <a:prstGeom prst="rect">
             <a:avLst/>

</xml_diff>